<commit_message>
Review-II deck: the hospital's own register (results slide, sixth demo picture)
New results slide read from the committed real-data page (the purpose test, what
the register answers, what the policy gates); the demonstration slide gains a
sixth picture; remaining-work text now says patient-level data is what may never
arrive. Deck rebuilt on the template with --without-instruction-slide.

Co-Authored-By: Claude Sonnet 5.5 <noreply@anthropic.com>
</commit_message>
<xml_diff>
--- a/Review-II.pptx
+++ b/Review-II.pptx
@@ -16,11 +16,12 @@
     <p:sldId id="269" r:id="rId20"/>
     <p:sldId id="261" r:id="rId7"/>
     <p:sldId id="262" r:id="rId8"/>
-    <p:sldId id="272" r:id="rId23"/>
+    <p:sldId id="273" r:id="rId24"/>
     <p:sldId id="263" r:id="rId9"/>
     <p:sldId id="264" r:id="rId10"/>
     <p:sldId id="270" r:id="rId21"/>
     <p:sldId id="271" r:id="rId22"/>
+    <p:sldId id="272" r:id="rId23"/>
     <p:sldId id="265" r:id="rId11"/>
     <p:sldId id="266" r:id="rId12"/>
     <p:sldId id="267" r:id="rId13"/>
@@ -1555,7 +1556,7 @@
                 <a:ea typeface="Calibri" pitchFamily="34" charset="-122"/>
                 <a:cs typeface="Calibri" pitchFamily="34" charset="-120"/>
               </a:rPr>
-              <a:t>15</a:t>
+              <a:t>16</a:t>
             </a:r>
             <a:endParaRPr lang="en-US" sz="1000" dirty="0"/>
           </a:p>
@@ -1787,7 +1788,7 @@
                 <a:ea typeface="Calibri" pitchFamily="34" charset="-122"/>
                 <a:cs typeface="Calibri" pitchFamily="34" charset="-120"/>
               </a:rPr>
-              <a:t>Nothing depends on the hospital dataset: the evaluation stands on synthetic data, the live portal and a public export we never saw. If an export is released, it is one column map and the same pipeline, and its slide rebuilds itself. Report: eight chapters and five appendices written, section references verified against the Gazette text, every table generated from the results and checked in CI. Manuscript: a complete first draft, to be fitted to the venue chosen with the guide — the one remaining point on the ledger.</a:t>
+              <a:t>Nothing depends on patient-level hospital data: the evaluation stands on synthetic data, the live portal and a public export we never saw, and the hospital's own collection register (real, aggregate, no patient in it) has been through the same pipeline. If a patient-level export is released, it is one column map and the same pipeline, and its slide rebuilds itself. Report: eight chapters and five appendices written, section references verified against the Gazette text, every table generated from the results and checked in CI. Manuscript: a complete first draft, to be fitted to the venue chosen with the guide — the one remaining point on the ledger.</a:t>
             </a:r>
             <a:endParaRPr lang="en-US" sz="1500" dirty="0"/>
           </a:p>
@@ -1901,7 +1902,7 @@
                 <a:ea typeface="Calibri" pitchFamily="34" charset="-122"/>
                 <a:cs typeface="Calibri" pitchFamily="34" charset="-120"/>
               </a:rPr>
-              <a:t>16</a:t>
+              <a:t>17</a:t>
             </a:r>
             <a:endParaRPr lang="en-US" sz="1000" dirty="0"/>
           </a:p>
@@ -2433,7 +2434,7 @@
                 <a:ea typeface="Calibri" pitchFamily="34" charset="-122"/>
                 <a:cs typeface="Calibri" pitchFamily="34" charset="-120"/>
               </a:rPr>
-              <a:t>17</a:t>
+              <a:t>18</a:t>
             </a:r>
             <a:endParaRPr lang="en-US" sz="1000" dirty="0"/>
           </a:p>
@@ -8853,7 +8854,7 @@
                 </a:solidFill>
                 <a:latin typeface="Calibri"/>
               </a:rPr>
-              <a:t>SSN, passport and licence numbers stopped at the adapter: no technique saw them and nothing exported them. The export found five defects our own data had not — identifiers read as numbers, a blanked column counted against a file, an empty source still benchmarked, one table kept per layer, a coverage ceiling set by the wrong technique — each fixed and tested; a hospital-shaped rehearsal had found four more. The coverage ceiling is measured from the source — 5 of the 18 fields the tasks need are not in the export, 2 are not in the chosen patient's records — so no technique is blamed for what the data lacks. If a hospital export is ever released, this slide is rebuilt from its run and nothing else changes.</a:t>
+              <a:t>SSN, passport and licence numbers stopped at the adapter: no technique saw them and nothing exported them. The export found five defects our own data had not — identifiers read as numbers, a blanked column counted against a file, an empty source still benchmarked, one table kept per layer, a coverage ceiling set by the wrong technique — each fixed and tested; a hospital-shaped rehearsal had found four more. The coverage ceiling is measured from the source — 5 of the 18 fields the tasks need are not in the export, 2 are not in the chosen patient's records — so no technique is blamed for what the data lacks. If a patient-level export is ever released, this slide is rebuilt from its run and nothing else changes.</a:t>
             </a:r>
           </a:p>
         </p:txBody>
@@ -8901,6 +8902,805 @@
 </file>
 
 <file path=ppt/slides/slide17.xml><?xml version="1.0" encoding="utf-8"?>
+<p:sld xmlns:a="http://schemas.openxmlformats.org/drawingml/2006/main" xmlns:p="http://schemas.openxmlformats.org/presentationml/2006/main" xmlns:r="http://schemas.openxmlformats.org/officeDocument/2006/relationships">
+  <p:cSld>
+    <p:spTree>
+      <p:nvGrpSpPr>
+        <p:cNvPr id="1" name=""/>
+        <p:cNvGrpSpPr/>
+        <p:nvPr/>
+      </p:nvGrpSpPr>
+      <p:grpSpPr/>
+      <p:sp>
+        <p:nvSpPr>
+          <p:cNvPr id="2" name="Text 0"/>
+          <p:cNvSpPr txBox="1"/>
+          <p:nvPr/>
+        </p:nvSpPr>
+        <p:spPr>
+          <a:xfrm>
+            <a:off x="11460175" y="6446520"/>
+            <a:ext cx="457200" cy="274320"/>
+          </a:xfrm>
+          <a:prstGeom prst="rect">
+            <a:avLst/>
+          </a:prstGeom>
+          <a:noFill/>
+          <a:ln/>
+        </p:spPr>
+        <p:txBody>
+          <a:bodyPr wrap="square" lIns="0" tIns="0" rIns="0" bIns="0" rtlCol="0" anchor="ctr"/>
+          <a:lstStyle/>
+          <a:p>
+            <a:pPr marL="0" indent="0" algn="r">
+              <a:buNone/>
+            </a:pPr>
+            <a:r>
+              <a:rPr lang="en-US" sz="1000" dirty="0">
+                <a:solidFill>
+                  <a:srgbClr val="808080"/>
+                </a:solidFill>
+                <a:latin typeface="Calibri" pitchFamily="34" charset="0"/>
+                <a:ea typeface="Calibri" pitchFamily="34" charset="-122"/>
+                <a:cs typeface="Calibri" pitchFamily="34" charset="-120"/>
+              </a:rPr>
+              <a:t>15</a:t>
+            </a:r>
+            <a:endParaRPr lang="en-US" sz="1000" dirty="0"/>
+          </a:p>
+        </p:txBody>
+      </p:sp>
+      <p:sp>
+        <p:nvSpPr>
+          <p:cNvPr id="3" name="Text 1"/>
+          <p:cNvSpPr txBox="1"/>
+          <p:nvPr/>
+        </p:nvSpPr>
+        <p:spPr>
+          <a:xfrm>
+            <a:off x="548640" y="320040"/>
+            <a:ext cx="9601200" cy="685800"/>
+          </a:xfrm>
+          <a:prstGeom prst="rect">
+            <a:avLst/>
+          </a:prstGeom>
+          <a:noFill/>
+          <a:ln/>
+        </p:spPr>
+        <p:txBody>
+          <a:bodyPr wrap="square" lIns="0" tIns="0" rIns="0" bIns="0" rtlCol="0" anchor="ctr"/>
+          <a:lstStyle/>
+          <a:p>
+            <a:pPr marL="0" indent="0">
+              <a:buNone/>
+            </a:pPr>
+            <a:r>
+              <a:rPr lang="en-US" sz="2800" b="1" dirty="0">
+                <a:solidFill>
+                  <a:srgbClr val="1D2F82"/>
+                </a:solidFill>
+                <a:latin typeface="Calibri" pitchFamily="34" charset="0"/>
+                <a:ea typeface="Calibri" pitchFamily="34" charset="-122"/>
+                <a:cs typeface="Calibri" pitchFamily="34" charset="-120"/>
+              </a:rPr>
+              <a:t>Results &amp; Analysis (contd.) — The Hospital's Own Register</a:t>
+            </a:r>
+            <a:endParaRPr lang="en-US" sz="2800" dirty="0"/>
+          </a:p>
+        </p:txBody>
+      </p:sp>
+      <p:pic>
+        <p:nvPicPr>
+          <p:cNvPr id="4" name="Image 0" descr="logo.png"/>
+          <p:cNvPicPr>
+            <a:picLocks noChangeAspect="1"/>
+          </p:cNvPicPr>
+          <p:nvPr/>
+        </p:nvPicPr>
+        <p:blipFill>
+          <a:blip r:embed="rId2"/>
+          <a:stretch>
+            <a:fillRect/>
+          </a:stretch>
+        </p:blipFill>
+        <p:spPr>
+          <a:xfrm>
+            <a:off x="10362895" y="320040"/>
+            <a:ext cx="1371600" cy="518746"/>
+          </a:xfrm>
+          <a:prstGeom prst="rect">
+            <a:avLst/>
+          </a:prstGeom>
+        </p:spPr>
+      </p:pic>
+      <p:sp>
+        <p:nvSpPr>
+          <p:cNvPr id="5" name="TextBox 4"/>
+          <p:cNvSpPr txBox="1"/>
+          <p:nvPr/>
+        </p:nvSpPr>
+        <p:spPr>
+          <a:xfrm>
+            <a:off x="640080" y="1234440"/>
+            <a:ext cx="10881360" cy="1188720"/>
+          </a:xfrm>
+          <a:prstGeom prst="rect">
+            <a:avLst/>
+          </a:prstGeom>
+          <a:noFill/>
+        </p:spPr>
+        <p:txBody>
+          <a:bodyPr wrap="square">
+            <a:spAutoFit/>
+          </a:bodyPr>
+          <a:lstStyle/>
+          <a:p>
+            <a:r>
+              <a:rPr sz="1150" b="0">
+                <a:solidFill>
+                  <a:srgbClr val="000000"/>
+                </a:solidFill>
+                <a:latin typeface="Calibri"/>
+              </a:rPr>
+              <a:t>The hospital's export arrived on 29 September and it is not patient-level: 731 daily records (14 Jun 2024 to 14 Jun 2026) of its collection register, receipts by payment mode, outpatient and inpatient. It went through the same four handling checks, the same adapter and the same rules: 33 of 34 columns were stopped at the door, one (the day total) was mapped to a catalogue field, and no direct identifier existed to reach any technique. One pull of it — 731 records of one financial field — was then judged under every purpose.</a:t>
+            </a:r>
+          </a:p>
+        </p:txBody>
+      </p:sp>
+      <p:graphicFrame>
+        <p:nvGraphicFramePr>
+          <p:cNvPr id="6" name="Table 5"/>
+          <p:cNvGraphicFramePr>
+            <a:graphicFrameLocks noGrp="1"/>
+          </p:cNvGraphicFramePr>
+          <p:nvPr/>
+        </p:nvGraphicFramePr>
+        <p:xfrm>
+          <a:off x="548640" y="2377440"/>
+          <a:ext cx="11091672" cy="1353312"/>
+        </p:xfrm>
+        <a:graphic>
+          <a:graphicData uri="http://schemas.openxmlformats.org/drawingml/2006/table">
+            <a:tbl>
+              <a:tblPr firstRow="1" bandRow="1">
+                <a:tableStyleId>{5C22544A-7EE6-4342-B048-85BDC9FD1C3A}</a:tableStyleId>
+              </a:tblPr>
+              <a:tblGrid>
+                <a:gridCol w="3017520"/>
+                <a:gridCol w="1005840"/>
+                <a:gridCol w="1188720"/>
+                <a:gridCol w="1737360"/>
+                <a:gridCol w="1005840"/>
+                <a:gridCol w="3136392"/>
+              </a:tblGrid>
+              <a:tr h="338328">
+                <a:tc>
+                  <a:txBody>
+                    <a:bodyPr/>
+                    <a:lstStyle/>
+                    <a:p>
+                      <a:r>
+                        <a:rPr sz="1200" b="1">
+                          <a:solidFill>
+                            <a:srgbClr val="FFFFFF"/>
+                          </a:solidFill>
+                          <a:latin typeface="Calibri"/>
+                        </a:rPr>
+                        <a:t>Purpose</a:t>
+                      </a:r>
+                    </a:p>
+                  </a:txBody>
+                  <a:tcPr>
+                    <a:solidFill>
+                      <a:srgbClr val="1D2F82"/>
+                    </a:solidFill>
+                  </a:tcPr>
+                </a:tc>
+                <a:tc>
+                  <a:txBody>
+                    <a:bodyPr/>
+                    <a:lstStyle/>
+                    <a:p>
+                      <a:r>
+                        <a:rPr sz="1200" b="1">
+                          <a:solidFill>
+                            <a:srgbClr val="FFFFFF"/>
+                          </a:solidFill>
+                          <a:latin typeface="Calibri"/>
+                        </a:rPr>
+                        <a:t>Score</a:t>
+                      </a:r>
+                    </a:p>
+                  </a:txBody>
+                  <a:tcPr>
+                    <a:solidFill>
+                      <a:srgbClr val="1D2F82"/>
+                    </a:solidFill>
+                  </a:tcPr>
+                </a:tc>
+                <a:tc>
+                  <a:txBody>
+                    <a:bodyPr/>
+                    <a:lstStyle/>
+                    <a:p>
+                      <a:r>
+                        <a:rPr sz="1200" b="1">
+                          <a:solidFill>
+                            <a:srgbClr val="FFFFFF"/>
+                          </a:solidFill>
+                          <a:latin typeface="Calibri"/>
+                        </a:rPr>
+                        <a:t>Rules met</a:t>
+                      </a:r>
+                    </a:p>
+                  </a:txBody>
+                  <a:tcPr>
+                    <a:solidFill>
+                      <a:srgbClr val="1D2F82"/>
+                    </a:solidFill>
+                  </a:tcPr>
+                </a:tc>
+                <a:tc>
+                  <a:txBody>
+                    <a:bodyPr/>
+                    <a:lstStyle/>
+                    <a:p>
+                      <a:r>
+                        <a:rPr sz="1200" b="1">
+                          <a:solidFill>
+                            <a:srgbClr val="FFFFFF"/>
+                          </a:solidFill>
+                          <a:latin typeface="Calibri"/>
+                        </a:rPr>
+                        <a:t>Rules failed</a:t>
+                      </a:r>
+                    </a:p>
+                  </a:txBody>
+                  <a:tcPr>
+                    <a:solidFill>
+                      <a:srgbClr val="1D2F82"/>
+                    </a:solidFill>
+                  </a:tcPr>
+                </a:tc>
+                <a:tc>
+                  <a:txBody>
+                    <a:bodyPr/>
+                    <a:lstStyle/>
+                    <a:p>
+                      <a:r>
+                        <a:rPr sz="1200" b="1">
+                          <a:solidFill>
+                            <a:srgbClr val="FFFFFF"/>
+                          </a:solidFill>
+                          <a:latin typeface="Calibri"/>
+                        </a:rPr>
+                        <a:t>Keep ≤</a:t>
+                      </a:r>
+                    </a:p>
+                  </a:txBody>
+                  <a:tcPr>
+                    <a:solidFill>
+                      <a:srgbClr val="1D2F82"/>
+                    </a:solidFill>
+                  </a:tcPr>
+                </a:tc>
+                <a:tc>
+                  <a:txBody>
+                    <a:bodyPr/>
+                    <a:lstStyle/>
+                    <a:p>
+                      <a:r>
+                        <a:rPr sz="1200" b="1">
+                          <a:solidFill>
+                            <a:srgbClr val="FFFFFF"/>
+                          </a:solidFill>
+                          <a:latin typeface="Calibri"/>
+                        </a:rPr>
+                        <a:t>Verdict</a:t>
+                      </a:r>
+                    </a:p>
+                  </a:txBody>
+                  <a:tcPr>
+                    <a:solidFill>
+                      <a:srgbClr val="1D2F82"/>
+                    </a:solidFill>
+                  </a:tcPr>
+                </a:tc>
+              </a:tr>
+              <a:tr h="338328">
+                <a:tc>
+                  <a:txBody>
+                    <a:bodyPr/>
+                    <a:lstStyle/>
+                    <a:p>
+                      <a:r>
+                        <a:rPr sz="1100" b="0">
+                          <a:solidFill>
+                            <a:srgbClr val="000000"/>
+                          </a:solidFill>
+                          <a:latin typeface="Calibri"/>
+                        </a:rPr>
+                        <a:t>billing settlement (declared)</a:t>
+                      </a:r>
+                    </a:p>
+                  </a:txBody>
+                  <a:tcPr>
+                    <a:solidFill>
+                      <a:srgbClr val="FFFFFF"/>
+                    </a:solidFill>
+                  </a:tcPr>
+                </a:tc>
+                <a:tc>
+                  <a:txBody>
+                    <a:bodyPr/>
+                    <a:lstStyle/>
+                    <a:p>
+                      <a:r>
+                        <a:rPr sz="1100" b="0">
+                          <a:solidFill>
+                            <a:srgbClr val="000000"/>
+                          </a:solidFill>
+                          <a:latin typeface="Calibri"/>
+                        </a:rPr>
+                        <a:t>1.000</a:t>
+                      </a:r>
+                    </a:p>
+                  </a:txBody>
+                  <a:tcPr>
+                    <a:solidFill>
+                      <a:srgbClr val="FFFFFF"/>
+                    </a:solidFill>
+                  </a:tcPr>
+                </a:tc>
+                <a:tc>
+                  <a:txBody>
+                    <a:bodyPr/>
+                    <a:lstStyle/>
+                    <a:p>
+                      <a:r>
+                        <a:rPr sz="1100" b="0">
+                          <a:solidFill>
+                            <a:srgbClr val="000000"/>
+                          </a:solidFill>
+                          <a:latin typeface="Calibri"/>
+                        </a:rPr>
+                        <a:t>7/7</a:t>
+                      </a:r>
+                    </a:p>
+                  </a:txBody>
+                  <a:tcPr>
+                    <a:solidFill>
+                      <a:srgbClr val="FFFFFF"/>
+                    </a:solidFill>
+                  </a:tcPr>
+                </a:tc>
+                <a:tc>
+                  <a:txBody>
+                    <a:bodyPr/>
+                    <a:lstStyle/>
+                    <a:p>
+                      <a:r>
+                        <a:rPr sz="1100" b="0">
+                          <a:solidFill>
+                            <a:srgbClr val="000000"/>
+                          </a:solidFill>
+                          <a:latin typeface="Calibri"/>
+                        </a:rPr>
+                        <a:t>—</a:t>
+                      </a:r>
+                    </a:p>
+                  </a:txBody>
+                  <a:tcPr>
+                    <a:solidFill>
+                      <a:srgbClr val="FFFFFF"/>
+                    </a:solidFill>
+                  </a:tcPr>
+                </a:tc>
+                <a:tc>
+                  <a:txBody>
+                    <a:bodyPr/>
+                    <a:lstStyle/>
+                    <a:p>
+                      <a:r>
+                        <a:rPr sz="1100" b="0">
+                          <a:solidFill>
+                            <a:srgbClr val="000000"/>
+                          </a:solidFill>
+                          <a:latin typeface="Calibri"/>
+                        </a:rPr>
+                        <a:t>365 d</a:t>
+                      </a:r>
+                    </a:p>
+                  </a:txBody>
+                  <a:tcPr>
+                    <a:solidFill>
+                      <a:srgbClr val="FFFFFF"/>
+                    </a:solidFill>
+                  </a:tcPr>
+                </a:tc>
+                <a:tc>
+                  <a:txBody>
+                    <a:bodyPr/>
+                    <a:lstStyle/>
+                    <a:p>
+                      <a:r>
+                        <a:rPr sz="1100" b="0">
+                          <a:solidFill>
+                            <a:srgbClr val="000000"/>
+                          </a:solidFill>
+                          <a:latin typeface="Calibri"/>
+                        </a:rPr>
+                        <a:t>lawful</a:t>
+                      </a:r>
+                    </a:p>
+                  </a:txBody>
+                  <a:tcPr>
+                    <a:solidFill>
+                      <a:srgbClr val="FFFFFF"/>
+                    </a:solidFill>
+                  </a:tcPr>
+                </a:tc>
+              </a:tr>
+              <a:tr h="338328">
+                <a:tc>
+                  <a:txBody>
+                    <a:bodyPr/>
+                    <a:lstStyle/>
+                    <a:p>
+                      <a:r>
+                        <a:rPr sz="1100" b="0">
+                          <a:solidFill>
+                            <a:srgbClr val="000000"/>
+                          </a:solidFill>
+                          <a:latin typeface="Calibri"/>
+                        </a:rPr>
+                        <a:t>care coordination</a:t>
+                      </a:r>
+                    </a:p>
+                  </a:txBody>
+                  <a:tcPr>
+                    <a:solidFill>
+                      <a:srgbClr val="FFFFFF"/>
+                    </a:solidFill>
+                  </a:tcPr>
+                </a:tc>
+                <a:tc>
+                  <a:txBody>
+                    <a:bodyPr/>
+                    <a:lstStyle/>
+                    <a:p>
+                      <a:r>
+                        <a:rPr sz="1100" b="0">
+                          <a:solidFill>
+                            <a:srgbClr val="000000"/>
+                          </a:solidFill>
+                          <a:latin typeface="Calibri"/>
+                        </a:rPr>
+                        <a:t>0.786</a:t>
+                      </a:r>
+                    </a:p>
+                  </a:txBody>
+                  <a:tcPr>
+                    <a:solidFill>
+                      <a:srgbClr val="FFFFFF"/>
+                    </a:solidFill>
+                  </a:tcPr>
+                </a:tc>
+                <a:tc>
+                  <a:txBody>
+                    <a:bodyPr/>
+                    <a:lstStyle/>
+                    <a:p>
+                      <a:r>
+                        <a:rPr sz="1100" b="0">
+                          <a:solidFill>
+                            <a:srgbClr val="000000"/>
+                          </a:solidFill>
+                          <a:latin typeface="Calibri"/>
+                        </a:rPr>
+                        <a:t>5/7</a:t>
+                      </a:r>
+                    </a:p>
+                  </a:txBody>
+                  <a:tcPr>
+                    <a:solidFill>
+                      <a:srgbClr val="FFFFFF"/>
+                    </a:solidFill>
+                  </a:tcPr>
+                </a:tc>
+                <a:tc>
+                  <a:txBody>
+                    <a:bodyPr/>
+                    <a:lstStyle/>
+                    <a:p>
+                      <a:r>
+                        <a:rPr sz="1100" b="0">
+                          <a:solidFill>
+                            <a:srgbClr val="000000"/>
+                          </a:solidFill>
+                          <a:latin typeface="Calibri"/>
+                        </a:rPr>
+                        <a:t>DM-01, NT-01</a:t>
+                      </a:r>
+                    </a:p>
+                  </a:txBody>
+                  <a:tcPr>
+                    <a:solidFill>
+                      <a:srgbClr val="FFFFFF"/>
+                    </a:solidFill>
+                  </a:tcPr>
+                </a:tc>
+                <a:tc>
+                  <a:txBody>
+                    <a:bodyPr/>
+                    <a:lstStyle/>
+                    <a:p>
+                      <a:r>
+                        <a:rPr sz="1100" b="0">
+                          <a:solidFill>
+                            <a:srgbClr val="000000"/>
+                          </a:solidFill>
+                          <a:latin typeface="Calibri"/>
+                        </a:rPr>
+                        <a:t>90 d</a:t>
+                      </a:r>
+                    </a:p>
+                  </a:txBody>
+                  <a:tcPr>
+                    <a:solidFill>
+                      <a:srgbClr val="FFFFFF"/>
+                    </a:solidFill>
+                  </a:tcPr>
+                </a:tc>
+                <a:tc>
+                  <a:txBody>
+                    <a:bodyPr/>
+                    <a:lstStyle/>
+                    <a:p>
+                      <a:r>
+                        <a:rPr sz="1100" b="0">
+                          <a:solidFill>
+                            <a:srgbClr val="000000"/>
+                          </a:solidFill>
+                          <a:latin typeface="Calibri"/>
+                        </a:rPr>
+                        <a:t>not lawful: out of scope: financial</a:t>
+                      </a:r>
+                    </a:p>
+                  </a:txBody>
+                  <a:tcPr>
+                    <a:solidFill>
+                      <a:srgbClr val="FFFFFF"/>
+                    </a:solidFill>
+                  </a:tcPr>
+                </a:tc>
+              </a:tr>
+              <a:tr h="338328">
+                <a:tc>
+                  <a:txBody>
+                    <a:bodyPr/>
+                    <a:lstStyle/>
+                    <a:p>
+                      <a:r>
+                        <a:rPr sz="1100" b="0">
+                          <a:solidFill>
+                            <a:srgbClr val="000000"/>
+                          </a:solidFill>
+                          <a:latin typeface="Calibri"/>
+                        </a:rPr>
+                        <a:t>patient registration</a:t>
+                      </a:r>
+                    </a:p>
+                  </a:txBody>
+                  <a:tcPr>
+                    <a:solidFill>
+                      <a:srgbClr val="FFFFFF"/>
+                    </a:solidFill>
+                  </a:tcPr>
+                </a:tc>
+                <a:tc>
+                  <a:txBody>
+                    <a:bodyPr/>
+                    <a:lstStyle/>
+                    <a:p>
+                      <a:r>
+                        <a:rPr sz="1100" b="0">
+                          <a:solidFill>
+                            <a:srgbClr val="000000"/>
+                          </a:solidFill>
+                          <a:latin typeface="Calibri"/>
+                        </a:rPr>
+                        <a:t>0.786</a:t>
+                      </a:r>
+                    </a:p>
+                  </a:txBody>
+                  <a:tcPr>
+                    <a:solidFill>
+                      <a:srgbClr val="FFFFFF"/>
+                    </a:solidFill>
+                  </a:tcPr>
+                </a:tc>
+                <a:tc>
+                  <a:txBody>
+                    <a:bodyPr/>
+                    <a:lstStyle/>
+                    <a:p>
+                      <a:r>
+                        <a:rPr sz="1100" b="0">
+                          <a:solidFill>
+                            <a:srgbClr val="000000"/>
+                          </a:solidFill>
+                          <a:latin typeface="Calibri"/>
+                        </a:rPr>
+                        <a:t>5/7</a:t>
+                      </a:r>
+                    </a:p>
+                  </a:txBody>
+                  <a:tcPr>
+                    <a:solidFill>
+                      <a:srgbClr val="FFFFFF"/>
+                    </a:solidFill>
+                  </a:tcPr>
+                </a:tc>
+                <a:tc>
+                  <a:txBody>
+                    <a:bodyPr/>
+                    <a:lstStyle/>
+                    <a:p>
+                      <a:r>
+                        <a:rPr sz="1100" b="0">
+                          <a:solidFill>
+                            <a:srgbClr val="000000"/>
+                          </a:solidFill>
+                          <a:latin typeface="Calibri"/>
+                        </a:rPr>
+                        <a:t>DM-01, NT-01</a:t>
+                      </a:r>
+                    </a:p>
+                  </a:txBody>
+                  <a:tcPr>
+                    <a:solidFill>
+                      <a:srgbClr val="FFFFFF"/>
+                    </a:solidFill>
+                  </a:tcPr>
+                </a:tc>
+                <a:tc>
+                  <a:txBody>
+                    <a:bodyPr/>
+                    <a:lstStyle/>
+                    <a:p>
+                      <a:r>
+                        <a:rPr sz="1100" b="0">
+                          <a:solidFill>
+                            <a:srgbClr val="000000"/>
+                          </a:solidFill>
+                          <a:latin typeface="Calibri"/>
+                        </a:rPr>
+                        <a:t>180 d</a:t>
+                      </a:r>
+                    </a:p>
+                  </a:txBody>
+                  <a:tcPr>
+                    <a:solidFill>
+                      <a:srgbClr val="FFFFFF"/>
+                    </a:solidFill>
+                  </a:tcPr>
+                </a:tc>
+                <a:tc>
+                  <a:txBody>
+                    <a:bodyPr/>
+                    <a:lstStyle/>
+                    <a:p>
+                      <a:r>
+                        <a:rPr sz="1100" b="0">
+                          <a:solidFill>
+                            <a:srgbClr val="000000"/>
+                          </a:solidFill>
+                          <a:latin typeface="Calibri"/>
+                        </a:rPr>
+                        <a:t>not lawful: out of scope: financial</a:t>
+                      </a:r>
+                    </a:p>
+                  </a:txBody>
+                  <a:tcPr>
+                    <a:solidFill>
+                      <a:srgbClr val="FFFFFF"/>
+                    </a:solidFill>
+                  </a:tcPr>
+                </a:tc>
+              </a:tr>
+            </a:tbl>
+          </a:graphicData>
+        </a:graphic>
+      </p:graphicFrame>
+      <p:sp>
+        <p:nvSpPr>
+          <p:cNvPr id="7" name="TextBox 6"/>
+          <p:cNvSpPr txBox="1"/>
+          <p:nvPr/>
+        </p:nvSpPr>
+        <p:spPr>
+          <a:xfrm>
+            <a:off x="640080" y="4114800"/>
+            <a:ext cx="10881360" cy="1828800"/>
+          </a:xfrm>
+          <a:prstGeom prst="rect">
+            <a:avLst/>
+          </a:prstGeom>
+          <a:noFill/>
+        </p:spPr>
+        <p:txBody>
+          <a:bodyPr wrap="square">
+            <a:spAutoFit/>
+          </a:bodyPr>
+          <a:lstStyle/>
+          <a:p>
+            <a:r>
+              <a:rPr sz="1100" b="0">
+                <a:solidFill>
+                  <a:srgbClr val="000000"/>
+                </a:solidFill>
+                <a:latin typeface="Calibri"/>
+              </a:rPr>
+              <a:t>What a register with no patient in it still answers, from totals alone: digital receipts rose from 59% to 71% of cash, card and online; outpatient and inpatient split 48% / 52%; Monday is the busiest weekday; 105 of 105 weekly totals reconcile with the sum of their days.</a:t>
+            </a:r>
+          </a:p>
+          <a:p>
+            <a:r>
+              <a:rPr sz="1100" b="0">
+                <a:solidFill>
+                  <a:srgbClr val="000000"/>
+                </a:solidFill>
+                <a:latin typeface="Calibri"/>
+              </a:rPr>
+              <a:t>Four questions need a person, and the policy gates them: none can be answered here, since all four need fields this export does not carry, and “Which diagnoses drive our costs” is refused outright under its own purpose (clinical is out of scope for billing). The tasks' 18 fields are 1 in this export, so every technique that reads only what a task needs ties at 1.000; the ranking rests on the synthetic, portal and public runs.</a:t>
+            </a:r>
+          </a:p>
+        </p:txBody>
+      </p:sp>
+      <p:sp>
+        <p:nvSpPr>
+          <p:cNvPr id="8" name="TextBox 7"/>
+          <p:cNvSpPr txBox="1"/>
+          <p:nvPr/>
+        </p:nvSpPr>
+        <p:spPr>
+          <a:xfrm>
+            <a:off x="640080" y="6172200"/>
+            <a:ext cx="10881360" cy="365760"/>
+          </a:xfrm>
+          <a:prstGeom prst="rect">
+            <a:avLst/>
+          </a:prstGeom>
+          <a:noFill/>
+        </p:spPr>
+        <p:txBody>
+          <a:bodyPr wrap="square">
+            <a:spAutoFit/>
+          </a:bodyPr>
+          <a:lstStyle/>
+          <a:p>
+            <a:r>
+              <a:rPr sz="1000" b="0">
+                <a:solidFill>
+                  <a:srgbClr val="808080"/>
+                </a:solidFill>
+                <a:latin typeface="Calibri"/>
+              </a:rPr>
+              <a:t>docs/review/real-data.html (tools/build_real_page.py); counts, ratios and indices only — no amount, no day's figure, no hospital or system name.</a:t>
+            </a:r>
+          </a:p>
+        </p:txBody>
+      </p:sp>
+    </p:spTree>
+  </p:cSld>
+  <p:clrMapOvr>
+    <a:masterClrMapping/>
+  </p:clrMapOvr>
+</p:sld>
+</file>
+
+<file path=ppt/slides/slide18.xml><?xml version="1.0" encoding="utf-8"?>
 <p:sld xmlns:a="http://schemas.openxmlformats.org/drawingml/2006/main" xmlns:p="http://schemas.openxmlformats.org/presentationml/2006/main" xmlns:r="http://schemas.openxmlformats.org/officeDocument/2006/relationships">
   <p:cSld>
     <p:spTree>
@@ -9164,7 +9964,7 @@
       </p:sp>
       <p:pic>
         <p:nvPicPr>
-          <p:cNvPr id="9" name="Picture 8" descr="journey-follow.png"/>
+          <p:cNvPr id="9" name="Picture 8" descr="real-questions.png"/>
           <p:cNvPicPr>
             <a:picLocks noChangeAspect="1"/>
           </p:cNvPicPr>
@@ -9178,8 +9978,8 @@
         </p:blipFill>
         <p:spPr>
           <a:xfrm>
-            <a:off x="8204907" y="1188720"/>
-            <a:ext cx="3268072" cy="1645920"/>
+            <a:off x="8065007" y="1473547"/>
+            <a:ext cx="3547872" cy="1361092"/>
           </a:xfrm>
           <a:prstGeom prst="rect">
             <a:avLst/>
@@ -9220,11 +10020,11 @@
                 </a:solidFill>
                 <a:latin typeface="Calibri"/>
               </a:rPr>
-              <a:t>3 · The journey of one entry</a:t>
+              <a:t>3 · The hospital's own register</a:t>
             </a:r>
             <a:r>
               <a:rPr sz="950"/>
-              <a:t>  —  One line of patients.csv through all seven stages. Follow the diagnosis through the agent on the billing job: the rail turns red at Extract and Purpose.</a:t>
+              <a:t>  —  Real hospital data with no patient in it: one pull judged under every purpose — lawful for the one it was taken for, refused by the other two with the rule named; six questions answered from totals, four gated.</a:t>
             </a:r>
             <a:r>
               <a:rPr sz="850">
@@ -9232,14 +10032,14 @@
                   <a:srgbClr val="808080"/>
                 </a:solidFill>
               </a:rPr>
-              <a:t>  [journey.html]</a:t>
+              <a:t>  [real-data.html]</a:t>
             </a:r>
           </a:p>
         </p:txBody>
       </p:sp>
       <p:pic>
         <p:nvPicPr>
-          <p:cNvPr id="11" name="Picture 10" descr="assistant-refusal.png"/>
+          <p:cNvPr id="11" name="Picture 10" descr="journey-follow.png"/>
           <p:cNvPicPr>
             <a:picLocks noChangeAspect="1"/>
           </p:cNvPicPr>
@@ -9253,8 +10053,8 @@
         </p:blipFill>
         <p:spPr>
           <a:xfrm>
-            <a:off x="2427732" y="4028447"/>
-            <a:ext cx="3547872" cy="1293360"/>
+            <a:off x="688539" y="3675888"/>
+            <a:ext cx="3268072" cy="1645920"/>
           </a:xfrm>
           <a:prstGeom prst="rect">
             <a:avLst/>
@@ -9274,7 +10074,7 @@
         </p:nvSpPr>
         <p:spPr>
           <a:xfrm>
-            <a:off x="2427732" y="5358384"/>
+            <a:off x="548640" y="5358384"/>
             <a:ext cx="3547871" cy="731520"/>
           </a:xfrm>
           <a:prstGeom prst="rect">
@@ -9295,11 +10095,11 @@
                 </a:solidFill>
                 <a:latin typeface="Calibri"/>
               </a:rPr>
-              <a:t>4 · Ask the assistant</a:t>
+              <a:t>4 · The journey of one entry</a:t>
             </a:r>
             <a:r>
               <a:rPr sz="950"/>
-              <a:t>  —  The panel types; reception asking for a diagnosis is refused before any detail is asked, with the three checks shown. Verified against the Python assistant on load.</a:t>
+              <a:t>  —  One line of patients.csv through all seven stages. Follow the diagnosis through the agent on the billing job: the rail turns red at Extract and Purpose.</a:t>
             </a:r>
             <a:r>
               <a:rPr sz="850">
@@ -9307,14 +10107,14 @@
                   <a:srgbClr val="808080"/>
                 </a:solidFill>
               </a:rPr>
-              <a:t>  [assistant.html]</a:t>
+              <a:t>  [journey.html]</a:t>
             </a:r>
           </a:p>
         </p:txBody>
       </p:sp>
       <p:pic>
         <p:nvPicPr>
-          <p:cNvPr id="13" name="Picture 12" descr="rules-vs-ai.png"/>
+          <p:cNvPr id="13" name="Picture 12" descr="assistant-refusal.png"/>
           <p:cNvPicPr>
             <a:picLocks noChangeAspect="1"/>
           </p:cNvPicPr>
@@ -9328,8 +10128,8 @@
         </p:blipFill>
         <p:spPr>
           <a:xfrm>
-            <a:off x="6208873" y="3675888"/>
-            <a:ext cx="3501957" cy="1645920"/>
+            <a:off x="4306823" y="4028447"/>
+            <a:ext cx="3547872" cy="1293360"/>
           </a:xfrm>
           <a:prstGeom prst="rect">
             <a:avLst/>
@@ -9349,7 +10149,7 @@
         </p:nvSpPr>
         <p:spPr>
           <a:xfrm>
-            <a:off x="6185916" y="5358384"/>
+            <a:off x="4306823" y="5358384"/>
             <a:ext cx="3547871" cy="731520"/>
           </a:xfrm>
           <a:prstGeom prst="rect">
@@ -9370,7 +10170,82 @@
                 </a:solidFill>
                 <a:latin typeface="Calibri"/>
               </a:rPr>
-              <a:t>5 · Rules vs just AI</a:t>
+              <a:t>5 · Ask the assistant</a:t>
+            </a:r>
+            <a:r>
+              <a:rPr sz="950"/>
+              <a:t>  —  The panel types; reception asking for a diagnosis is refused before any detail is asked, with the three checks shown. Verified against the Python assistant on load.</a:t>
+            </a:r>
+            <a:r>
+              <a:rPr sz="850">
+                <a:solidFill>
+                  <a:srgbClr val="808080"/>
+                </a:solidFill>
+              </a:rPr>
+              <a:t>  [assistant.html]</a:t>
+            </a:r>
+          </a:p>
+        </p:txBody>
+      </p:sp>
+      <p:pic>
+        <p:nvPicPr>
+          <p:cNvPr id="15" name="Picture 14" descr="rules-vs-ai.png"/>
+          <p:cNvPicPr>
+            <a:picLocks noChangeAspect="1"/>
+          </p:cNvPicPr>
+          <p:nvPr/>
+        </p:nvPicPr>
+        <p:blipFill>
+          <a:blip r:embed="rId8"/>
+          <a:stretch>
+            <a:fillRect/>
+          </a:stretch>
+        </p:blipFill>
+        <p:spPr>
+          <a:xfrm>
+            <a:off x="8087965" y="3675888"/>
+            <a:ext cx="3501957" cy="1645920"/>
+          </a:xfrm>
+          <a:prstGeom prst="rect">
+            <a:avLst/>
+          </a:prstGeom>
+          <a:ln w="6350">
+            <a:solidFill>
+              <a:srgbClr val="808080"/>
+            </a:solidFill>
+          </a:ln>
+        </p:spPr>
+      </p:pic>
+      <p:sp>
+        <p:nvSpPr>
+          <p:cNvPr id="16" name="TextBox 15"/>
+          <p:cNvSpPr txBox="1"/>
+          <p:nvPr/>
+        </p:nvSpPr>
+        <p:spPr>
+          <a:xfrm>
+            <a:off x="8065007" y="5358384"/>
+            <a:ext cx="3547871" cy="731520"/>
+          </a:xfrm>
+          <a:prstGeom prst="rect">
+            <a:avLst/>
+          </a:prstGeom>
+          <a:noFill/>
+        </p:spPr>
+        <p:txBody>
+          <a:bodyPr wrap="square">
+            <a:spAutoFit/>
+          </a:bodyPr>
+          <a:lstStyle/>
+          <a:p>
+            <a:r>
+              <a:rPr sz="950" b="1">
+                <a:solidFill>
+                  <a:srgbClr val="1D2F82"/>
+                </a:solidFill>
+                <a:latin typeface="Calibri"/>
+              </a:rPr>
+              <a:t>6 · Rules vs just AI</a:t>
             </a:r>
             <a:r>
               <a:rPr sz="950"/>
@@ -9389,7 +10264,7 @@
       </p:sp>
       <p:sp>
         <p:nvSpPr>
-          <p:cNvPr id="15" name="TextBox 14"/>
+          <p:cNvPr id="17" name="TextBox 16"/>
           <p:cNvSpPr txBox="1"/>
           <p:nvPr/>
         </p:nvSpPr>
@@ -14498,7 +15373,7 @@
                 <a:ea typeface="Calibri" pitchFamily="34" charset="-122"/>
                 <a:cs typeface="Calibri" pitchFamily="34" charset="-120"/>
               </a:rPr>
-              <a:t>Modules developed and integrated (src/, 315 tests, CI diffs the regenerated benchmark):</a:t>
+              <a:t>Modules developed and integrated (src/, 316 tests, CI diffs the regenerated benchmark):</a:t>
             </a:r>
             <a:endParaRPr lang="en-US" sz="1500" dirty="0"/>
           </a:p>
@@ -14561,7 +15436,7 @@
                 <a:ea typeface="Calibri" pitchFamily="34" charset="-122"/>
                 <a:cs typeface="Calibri" pitchFamily="34" charset="-120"/>
               </a:rPr>
-              <a:t>interop/ — HL7 v2 (ADT, ORM, ORU, DFT) and FHIR R4 (12 resources incl. AuditEvent) shapers; normalise + export audit. agent/ — 13-function registry, session state machine, grounded guidance. tools/mock_portal — the Flask fixture built as a system we do not control. scripts/rehearse_day_one.py — the real-data procedure rehearsed on a hospital-shaped export, with a leak audit. tools/build_review_pages.py — four offline demo pages built from real runs.</a:t>
+              <a:t>interop/ — HL7 v2 (ADT, ORM, ORU, DFT) and FHIR R4 (12 resources incl. AuditEvent) shapers; normalise + export audit. agent/ — 13-function registry, session state machine, grounded guidance. tools/mock_portal — the Flask fixture built as a system we do not control. scripts/rehearse_day_one.py — the real-data procedure rehearsed on a hospital-shaped export, with a leak audit. tools/build_review_pages.py — six offline demo pages built from real runs.</a:t>
             </a:r>
             <a:endParaRPr lang="en-US" sz="1500" dirty="0"/>
           </a:p>

</xml_diff>